<commit_message>
Employeur/client fiables, exports LinkedIn, suppression Méthode et Environnement
- Employeur jamais déduit de l'en-tête, du titre ou des coordonnées (contrôle déterministe + contre-vérification)
- Affichage « Employeur · Client : X », mention Freelance
- Lecture de la structure des exports LinkedIn ; dossier Input par défaut
- Dates lues par le code, souhaits jamais présentés comme compétences
- Photo : recadrage qui garde le visage

Co-Authored-By: Claude Opus 5.5 <noreply@anthropic.com>
</commit_message>
<xml_diff>
--- a/cv_formatter/assets/modele_cv_logiclever.pptx
+++ b/cv_formatter/assets/modele_cv_logiclever.pptx
@@ -2499,102 +2499,6 @@
           <a:chExt cx="0" cy="0"/>
         </a:xfrm>
       </p:grpSpPr>
-      <p:sp>
-        <p:nvSpPr>
-          <p:cNvPr id="100" name="Google Shape;100;p19"/>
-          <p:cNvSpPr txBox="1"/>
-          <p:nvPr/>
-        </p:nvSpPr>
-        <p:spPr>
-          <a:xfrm>
-            <a:off x="4971475" y="3924353"/>
-            <a:ext cx="2328600" cy="1425300"/>
-          </a:xfrm>
-          <a:prstGeom prst="rect">
-            <a:avLst/>
-          </a:prstGeom>
-          <a:noFill/>
-          <a:ln>
-            <a:noFill/>
-          </a:ln>
-        </p:spPr>
-        <p:txBody>
-          <a:bodyPr anchorCtr="0" anchor="t" bIns="91425" lIns="91425" spcFirstLastPara="1" rIns="91425" wrap="square" tIns="91425">
-            <a:normAutofit/>
-          </a:bodyPr>
-          <a:lstStyle/>
-          <a:p>
-            <a:pPr indent="0" lvl="0" marL="0" rtl="0" algn="l">
-              <a:lnSpc>
-                <a:spcPct val="115000"/>
-              </a:lnSpc>
-              <a:spcBef>
-                <a:spcPts val="1000"/>
-              </a:spcBef>
-              <a:spcAft>
-                <a:spcPts val="0"/>
-              </a:spcAft>
-              <a:buNone/>
-            </a:pPr>
-            <a:r>
-              <a:rPr b="1" lang="fr" sz="1000">
-                <a:solidFill>
-                  <a:schemeClr val="dk1"/>
-                </a:solidFill>
-                <a:latin typeface="Lexend"/>
-                <a:ea typeface="Lexend"/>
-                <a:cs typeface="Lexend"/>
-                <a:sym typeface="Lexend"/>
-              </a:rPr>
-              <a:t>MÉTHODE</a:t>
-            </a:r>
-            <a:endParaRPr b="1" sz="1000">
-              <a:solidFill>
-                <a:schemeClr val="dk1"/>
-              </a:solidFill>
-              <a:latin typeface="Lexend"/>
-              <a:ea typeface="Lexend"/>
-              <a:cs typeface="Lexend"/>
-              <a:sym typeface="Lexend"/>
-            </a:endParaRPr>
-          </a:p>
-          <a:p>
-            <a:pPr indent="0" lvl="0" marL="0" rtl="0" algn="l">
-              <a:lnSpc>
-                <a:spcPct val="115000"/>
-              </a:lnSpc>
-              <a:spcBef>
-                <a:spcPts val="0"/>
-              </a:spcBef>
-              <a:spcAft>
-                <a:spcPts val="0"/>
-              </a:spcAft>
-              <a:buNone/>
-            </a:pPr>
-            <a:r>
-              <a:rPr lang="fr" sz="1000">
-                <a:solidFill>
-                  <a:schemeClr val="dk1"/>
-                </a:solidFill>
-                <a:latin typeface="Lexend"/>
-                <a:ea typeface="Lexend"/>
-                <a:cs typeface="Lexend"/>
-                <a:sym typeface="Lexend"/>
-              </a:rPr>
-              <a:t>{{methode}}</a:t>
-            </a:r>
-            <a:endParaRPr sz="1000">
-              <a:solidFill>
-                <a:schemeClr val="dk1"/>
-              </a:solidFill>
-              <a:latin typeface="Lexend"/>
-              <a:ea typeface="Lexend"/>
-              <a:cs typeface="Lexend"/>
-              <a:sym typeface="Lexend"/>
-            </a:endParaRPr>
-          </a:p>
-        </p:txBody>
-      </p:sp>
       <p:sp>
         <p:nvSpPr>
           <p:cNvPr id="101" name="Google Shape;101;p19"/>

</xml_diff>

<commit_message>
Colonne droite : EXPERTISE, SI & OUTILS puis LANGUES, libellés en majuscules (modèle mis à jour) ; version 1.2.0
Co-Authored-By: Claude Opus 5.5 <noreply@anthropic.com>
</commit_message>
<xml_diff>
--- a/cv_formatter/assets/modele_cv_logiclever.pptx
+++ b/cv_formatter/assets/modele_cv_logiclever.pptx
@@ -5966,7 +5966,7 @@
         </p:nvSpPr>
         <p:spPr>
           <a:xfrm>
-            <a:off x="4971475" y="6259700"/>
+            <a:off x="4971475" y="5349676"/>
             <a:ext cx="2328600" cy="585600"/>
           </a:xfrm>
           <a:prstGeom prst="rect">
@@ -6010,7 +6010,7 @@
                 <a:cs typeface="Lexend"/>
                 <a:sym typeface="Lexend"/>
               </a:rPr>
-              <a:t>SI</a:t>
+              <a:t>SI &amp; OUTILS</a:t>
             </a:r>
             <a:endParaRPr b="1" sz="1000">
               <a:solidFill>
@@ -6072,7 +6072,7 @@
         </p:nvSpPr>
         <p:spPr>
           <a:xfrm>
-            <a:off x="4971475" y="5349676"/>
+            <a:off x="4971475" y="5935276"/>
             <a:ext cx="2328600" cy="909900"/>
           </a:xfrm>
           <a:prstGeom prst="rect">

</xml_diff>